<commit_message>
chore: rename product to 人才决策Agent
</commit_message>
<xml_diff>
--- a/docs/GOAI无界应用_方案PPT.pptx
+++ b/docs/GOAI无界应用_方案PPT.pptx
@@ -2,24 +2,24 @@
 <file path=ppt/presentation.xml><?xml version="1.0" encoding="utf-8"?>
 <p:presentation xmlns:p="http://schemas.openxmlformats.org/presentationml/2006/main">
   <p:sldMasterIdLst>
-    <p:sldMasterId xmlns:r="http://schemas.openxmlformats.org/officeDocument/2006/relationships" id="2147483648" r:id="R744ad4efaec84991"/>
+    <p:sldMasterId xmlns:r="http://schemas.openxmlformats.org/officeDocument/2006/relationships" id="2147483648" r:id="R99ea8febdb8b4a85"/>
   </p:sldMasterIdLst>
   <p:notesMasterIdLst>
-    <p:notesMasterId xmlns:r="http://schemas.openxmlformats.org/officeDocument/2006/relationships" r:id="Re5a76da881ba4566"/>
+    <p:notesMasterId xmlns:r="http://schemas.openxmlformats.org/officeDocument/2006/relationships" r:id="R59664e9993844006"/>
   </p:notesMasterIdLst>
   <p:sldIdLst>
-    <p:sldId xmlns:r="http://schemas.openxmlformats.org/officeDocument/2006/relationships" id="256" r:id="R9f3b85d4b9c44f56"/>
-    <p:sldId xmlns:r="http://schemas.openxmlformats.org/officeDocument/2006/relationships" id="257" r:id="R51d5e5244e12444f"/>
-    <p:sldId xmlns:r="http://schemas.openxmlformats.org/officeDocument/2006/relationships" id="258" r:id="R2041b1f60eee4fcd"/>
-    <p:sldId xmlns:r="http://schemas.openxmlformats.org/officeDocument/2006/relationships" id="259" r:id="R1053e59f40e04f4c"/>
-    <p:sldId xmlns:r="http://schemas.openxmlformats.org/officeDocument/2006/relationships" id="260" r:id="R577ff3f3d81c41e7"/>
-    <p:sldId xmlns:r="http://schemas.openxmlformats.org/officeDocument/2006/relationships" id="261" r:id="R79ccdb8c78944410"/>
-    <p:sldId xmlns:r="http://schemas.openxmlformats.org/officeDocument/2006/relationships" id="262" r:id="R080b10246ad245fe"/>
-    <p:sldId xmlns:r="http://schemas.openxmlformats.org/officeDocument/2006/relationships" id="263" r:id="Rfe7bb1ef9e0e42ef"/>
-    <p:sldId xmlns:r="http://schemas.openxmlformats.org/officeDocument/2006/relationships" id="264" r:id="R4e7fbe717f3d493d"/>
-    <p:sldId xmlns:r="http://schemas.openxmlformats.org/officeDocument/2006/relationships" id="265" r:id="Rfe98f5f998fd4853"/>
-    <p:sldId xmlns:r="http://schemas.openxmlformats.org/officeDocument/2006/relationships" id="266" r:id="R324a07ed30e7440a"/>
-    <p:sldId xmlns:r="http://schemas.openxmlformats.org/officeDocument/2006/relationships" id="267" r:id="Rffb6cdfdb47548d6"/>
+    <p:sldId xmlns:r="http://schemas.openxmlformats.org/officeDocument/2006/relationships" id="256" r:id="Raab387011bdb4f43"/>
+    <p:sldId xmlns:r="http://schemas.openxmlformats.org/officeDocument/2006/relationships" id="257" r:id="Rfdca46a0e0b34f8b"/>
+    <p:sldId xmlns:r="http://schemas.openxmlformats.org/officeDocument/2006/relationships" id="258" r:id="Rd44935f6eb604b12"/>
+    <p:sldId xmlns:r="http://schemas.openxmlformats.org/officeDocument/2006/relationships" id="259" r:id="R7d4c3025d2894704"/>
+    <p:sldId xmlns:r="http://schemas.openxmlformats.org/officeDocument/2006/relationships" id="260" r:id="Ra7a5606478434966"/>
+    <p:sldId xmlns:r="http://schemas.openxmlformats.org/officeDocument/2006/relationships" id="261" r:id="R861b998e460f40ca"/>
+    <p:sldId xmlns:r="http://schemas.openxmlformats.org/officeDocument/2006/relationships" id="262" r:id="R2a9a8a81125d416d"/>
+    <p:sldId xmlns:r="http://schemas.openxmlformats.org/officeDocument/2006/relationships" id="263" r:id="Rd8ba048048a347dd"/>
+    <p:sldId xmlns:r="http://schemas.openxmlformats.org/officeDocument/2006/relationships" id="264" r:id="R993c6925fed748e8"/>
+    <p:sldId xmlns:r="http://schemas.openxmlformats.org/officeDocument/2006/relationships" id="265" r:id="Rb8a5e31ec9a34c8c"/>
+    <p:sldId xmlns:r="http://schemas.openxmlformats.org/officeDocument/2006/relationships" id="266" r:id="R6a16362d967c4665"/>
+    <p:sldId xmlns:r="http://schemas.openxmlformats.org/officeDocument/2006/relationships" id="267" r:id="Reacf6f9b508146b6"/>
   </p:sldIdLst>
   <p:sldSz cx="9144000" cy="5143500"/>
   <p:notesSz cx="6858000" cy="9144000"/>
@@ -1351,7 +1351,7 @@
   </p:cSld>
   <p:clrMap bg1="lt1" tx1="dk1" bg2="lt2" tx2="dk2" accent1="accent1" accent2="accent2" accent3="accent3" accent4="accent4" accent5="accent5" accent6="accent6" hlink="hlink" folHlink="folHlink"/>
   <p:sldLayoutIdLst>
-    <p:sldLayoutId xmlns:r="http://schemas.openxmlformats.org/officeDocument/2006/relationships" id="2147483649" r:id="R5f7d03863ddc4080"/>
+    <p:sldLayoutId xmlns:r="http://schemas.openxmlformats.org/officeDocument/2006/relationships" id="2147483649" r:id="R24b591db4b01474b"/>
   </p:sldLayoutIdLst>
   <p:hf sldNum="0" hdr="0" ftr="0" dt="0"/>
   <p:txStyles>
@@ -2003,7 +2003,7 @@
                 <a:ea typeface="Microsoft YaHei"/>
                 <a:cs typeface="Microsoft YaHei"/>
               </a:rPr>
-              <a:t>智聘Agent</a:t>
+              <a:t>人才决策Agent</a:t>
             </a:r>
             <a:endParaRPr sz="5000"/>
           </a:p>
@@ -2137,7 +2137,7 @@
           <p:nvPr/>
         </p:nvPicPr>
         <p:blipFill>
-          <a:blip xmlns:r="http://schemas.openxmlformats.org/officeDocument/2006/relationships" xmlns:a="http://schemas.openxmlformats.org/drawingml/2006/main" r:embed="R75ca800908264527"/>
+          <a:blip xmlns:r="http://schemas.openxmlformats.org/officeDocument/2006/relationships" xmlns:a="http://schemas.openxmlformats.org/drawingml/2006/main" r:embed="R40b3a850073f4116"/>
           <a:stretch xmlns:a="http://schemas.openxmlformats.org/drawingml/2006/main">
             <a:fillRect l="0" t="0" r="0" b="0"/>
           </a:stretch>
@@ -4065,7 +4065,7 @@
           <p:nvPr/>
         </p:nvPicPr>
         <p:blipFill>
-          <a:blip xmlns:r="http://schemas.openxmlformats.org/officeDocument/2006/relationships" xmlns:a="http://schemas.openxmlformats.org/drawingml/2006/main" r:embed="R66516c11e5694c62"/>
+          <a:blip xmlns:r="http://schemas.openxmlformats.org/officeDocument/2006/relationships" xmlns:a="http://schemas.openxmlformats.org/drawingml/2006/main" r:embed="R89381edf85794b41"/>
           <a:stretch xmlns:a="http://schemas.openxmlformats.org/drawingml/2006/main">
             <a:fillRect l="0" t="0" r="0" b="0"/>
           </a:stretch>
@@ -5009,7 +5009,7 @@
           <p:nvPr/>
         </p:nvPicPr>
         <p:blipFill>
-          <a:blip xmlns:r="http://schemas.openxmlformats.org/officeDocument/2006/relationships" xmlns:a="http://schemas.openxmlformats.org/drawingml/2006/main" r:embed="R5596977b9a734058"/>
+          <a:blip xmlns:r="http://schemas.openxmlformats.org/officeDocument/2006/relationships" xmlns:a="http://schemas.openxmlformats.org/drawingml/2006/main" r:embed="R31eb74da59984640"/>
           <a:stretch xmlns:a="http://schemas.openxmlformats.org/drawingml/2006/main">
             <a:fillRect l="0" t="0" r="0" b="0"/>
           </a:stretch>
@@ -5188,7 +5188,7 @@
           <p:nvPr/>
         </p:nvPicPr>
         <p:blipFill>
-          <a:blip xmlns:r="http://schemas.openxmlformats.org/officeDocument/2006/relationships" xmlns:a="http://schemas.openxmlformats.org/drawingml/2006/main" r:embed="R5d1452fb47bf44af"/>
+          <a:blip xmlns:r="http://schemas.openxmlformats.org/officeDocument/2006/relationships" xmlns:a="http://schemas.openxmlformats.org/drawingml/2006/main" r:embed="R5193e755e3c94ca3"/>
           <a:stretch xmlns:a="http://schemas.openxmlformats.org/drawingml/2006/main">
             <a:fillRect l="0" t="0" r="0" b="0"/>
           </a:stretch>
@@ -6975,7 +6975,7 @@
           <p:nvPr/>
         </p:nvPicPr>
         <p:blipFill>
-          <a:blip xmlns:r="http://schemas.openxmlformats.org/officeDocument/2006/relationships" xmlns:a="http://schemas.openxmlformats.org/drawingml/2006/main" r:embed="R3d4da0f7ad904ee3"/>
+          <a:blip xmlns:r="http://schemas.openxmlformats.org/officeDocument/2006/relationships" xmlns:a="http://schemas.openxmlformats.org/drawingml/2006/main" r:embed="R3846ff6c06bf461b"/>
           <a:stretch xmlns:a="http://schemas.openxmlformats.org/drawingml/2006/main">
             <a:fillRect l="0" t="0" r="0" b="0"/>
           </a:stretch>
@@ -7154,7 +7154,7 @@
           <p:nvPr/>
         </p:nvPicPr>
         <p:blipFill>
-          <a:blip xmlns:r="http://schemas.openxmlformats.org/officeDocument/2006/relationships" xmlns:a="http://schemas.openxmlformats.org/drawingml/2006/main" r:embed="R29b26d99f41c4d31"/>
+          <a:blip xmlns:r="http://schemas.openxmlformats.org/officeDocument/2006/relationships" xmlns:a="http://schemas.openxmlformats.org/drawingml/2006/main" r:embed="R4290bebb0a7e4bb0"/>
           <a:stretch xmlns:a="http://schemas.openxmlformats.org/drawingml/2006/main">
             <a:fillRect l="0" t="0" r="0" b="0"/>
           </a:stretch>
@@ -7333,7 +7333,7 @@
           <p:nvPr/>
         </p:nvPicPr>
         <p:blipFill>
-          <a:blip xmlns:r="http://schemas.openxmlformats.org/officeDocument/2006/relationships" xmlns:a="http://schemas.openxmlformats.org/drawingml/2006/main" r:embed="R68b103b0880a450a"/>
+          <a:blip xmlns:r="http://schemas.openxmlformats.org/officeDocument/2006/relationships" xmlns:a="http://schemas.openxmlformats.org/drawingml/2006/main" r:embed="R7d252a353dad49bc"/>
           <a:stretch xmlns:a="http://schemas.openxmlformats.org/drawingml/2006/main">
             <a:fillRect l="0" t="0" r="0" b="0"/>
           </a:stretch>
@@ -7512,7 +7512,7 @@
           <p:nvPr/>
         </p:nvPicPr>
         <p:blipFill>
-          <a:blip xmlns:r="http://schemas.openxmlformats.org/officeDocument/2006/relationships" xmlns:a="http://schemas.openxmlformats.org/drawingml/2006/main" r:embed="R54c9950667f04bff"/>
+          <a:blip xmlns:r="http://schemas.openxmlformats.org/officeDocument/2006/relationships" xmlns:a="http://schemas.openxmlformats.org/drawingml/2006/main" r:embed="Ra8f8d3710ceb4246"/>
           <a:stretch xmlns:a="http://schemas.openxmlformats.org/drawingml/2006/main">
             <a:fillRect l="0" t="0" r="0" b="0"/>
           </a:stretch>
@@ -7691,7 +7691,7 @@
           <p:nvPr/>
         </p:nvPicPr>
         <p:blipFill>
-          <a:blip xmlns:r="http://schemas.openxmlformats.org/officeDocument/2006/relationships" xmlns:a="http://schemas.openxmlformats.org/drawingml/2006/main" r:embed="Rc781b78c27f748a2"/>
+          <a:blip xmlns:r="http://schemas.openxmlformats.org/officeDocument/2006/relationships" xmlns:a="http://schemas.openxmlformats.org/drawingml/2006/main" r:embed="Rbf4cc593bb8e49ff"/>
           <a:stretch xmlns:a="http://schemas.openxmlformats.org/drawingml/2006/main">
             <a:fillRect l="0" t="0" r="0" b="0"/>
           </a:stretch>
@@ -7843,7 +7843,7 @@
           <p:nvPr/>
         </p:nvPicPr>
         <p:blipFill>
-          <a:blip xmlns:r="http://schemas.openxmlformats.org/officeDocument/2006/relationships" xmlns:a="http://schemas.openxmlformats.org/drawingml/2006/main" r:embed="R39a31f123240467d"/>
+          <a:blip xmlns:r="http://schemas.openxmlformats.org/officeDocument/2006/relationships" xmlns:a="http://schemas.openxmlformats.org/drawingml/2006/main" r:embed="R2ebbc7997a1c4a6d"/>
           <a:stretch xmlns:a="http://schemas.openxmlformats.org/drawingml/2006/main">
             <a:fillRect l="0" t="0" r="0" b="0"/>
           </a:stretch>
@@ -8189,7 +8189,7 @@
           <p:nvPr/>
         </p:nvPicPr>
         <p:blipFill>
-          <a:blip xmlns:r="http://schemas.openxmlformats.org/officeDocument/2006/relationships" xmlns:a="http://schemas.openxmlformats.org/drawingml/2006/main" r:embed="R60e609a39651426f"/>
+          <a:blip xmlns:r="http://schemas.openxmlformats.org/officeDocument/2006/relationships" xmlns:a="http://schemas.openxmlformats.org/drawingml/2006/main" r:embed="R82b6540d98cc4276"/>
           <a:stretch xmlns:a="http://schemas.openxmlformats.org/drawingml/2006/main">
             <a:fillRect l="0" t="0" r="0" b="0"/>
           </a:stretch>
@@ -8414,7 +8414,7 @@
           <p:nvPr/>
         </p:nvPicPr>
         <p:blipFill>
-          <a:blip xmlns:r="http://schemas.openxmlformats.org/officeDocument/2006/relationships" xmlns:a="http://schemas.openxmlformats.org/drawingml/2006/main" r:embed="R6340b7ac727e4503"/>
+          <a:blip xmlns:r="http://schemas.openxmlformats.org/officeDocument/2006/relationships" xmlns:a="http://schemas.openxmlformats.org/drawingml/2006/main" r:embed="R85fc8588c03b41f5"/>
           <a:stretch xmlns:a="http://schemas.openxmlformats.org/drawingml/2006/main">
             <a:fillRect l="0" t="0" r="0" b="0"/>
           </a:stretch>
@@ -8639,7 +8639,7 @@
           <p:nvPr/>
         </p:nvPicPr>
         <p:blipFill>
-          <a:blip xmlns:r="http://schemas.openxmlformats.org/officeDocument/2006/relationships" xmlns:a="http://schemas.openxmlformats.org/drawingml/2006/main" r:embed="Rb68857f051ca43c8"/>
+          <a:blip xmlns:r="http://schemas.openxmlformats.org/officeDocument/2006/relationships" xmlns:a="http://schemas.openxmlformats.org/drawingml/2006/main" r:embed="Ref33d3e4c66a458a"/>
           <a:stretch xmlns:a="http://schemas.openxmlformats.org/drawingml/2006/main">
             <a:fillRect l="0" t="0" r="0" b="0"/>
           </a:stretch>
@@ -9829,7 +9829,7 @@
           <p:nvPr/>
         </p:nvPicPr>
         <p:blipFill>
-          <a:blip xmlns:r="http://schemas.openxmlformats.org/officeDocument/2006/relationships" xmlns:a="http://schemas.openxmlformats.org/drawingml/2006/main" r:embed="R0e1e65d9e6a641c4"/>
+          <a:blip xmlns:r="http://schemas.openxmlformats.org/officeDocument/2006/relationships" xmlns:a="http://schemas.openxmlformats.org/drawingml/2006/main" r:embed="Red8f22bfb72140fa"/>
           <a:stretch xmlns:a="http://schemas.openxmlformats.org/drawingml/2006/main">
             <a:fillRect l="0" t="0" r="0" b="0"/>
           </a:stretch>
@@ -10008,7 +10008,7 @@
           <p:nvPr/>
         </p:nvPicPr>
         <p:blipFill>
-          <a:blip xmlns:r="http://schemas.openxmlformats.org/officeDocument/2006/relationships" xmlns:a="http://schemas.openxmlformats.org/drawingml/2006/main" r:embed="R79ae7e45fee24dcb"/>
+          <a:blip xmlns:r="http://schemas.openxmlformats.org/officeDocument/2006/relationships" xmlns:a="http://schemas.openxmlformats.org/drawingml/2006/main" r:embed="R08c987d3d48f469b"/>
           <a:stretch xmlns:a="http://schemas.openxmlformats.org/drawingml/2006/main">
             <a:fillRect l="0" t="0" r="0" b="0"/>
           </a:stretch>
@@ -10187,7 +10187,7 @@
           <p:nvPr/>
         </p:nvPicPr>
         <p:blipFill>
-          <a:blip xmlns:r="http://schemas.openxmlformats.org/officeDocument/2006/relationships" xmlns:a="http://schemas.openxmlformats.org/drawingml/2006/main" r:embed="Rff250a679a794c79"/>
+          <a:blip xmlns:r="http://schemas.openxmlformats.org/officeDocument/2006/relationships" xmlns:a="http://schemas.openxmlformats.org/drawingml/2006/main" r:embed="Rdfbeaaf6ae1f4fd0"/>
           <a:stretch xmlns:a="http://schemas.openxmlformats.org/drawingml/2006/main">
             <a:fillRect l="0" t="0" r="0" b="0"/>
           </a:stretch>
@@ -10366,7 +10366,7 @@
           <p:nvPr/>
         </p:nvPicPr>
         <p:blipFill>
-          <a:blip xmlns:r="http://schemas.openxmlformats.org/officeDocument/2006/relationships" xmlns:a="http://schemas.openxmlformats.org/drawingml/2006/main" r:embed="Rfbc30a21961e47de"/>
+          <a:blip xmlns:r="http://schemas.openxmlformats.org/officeDocument/2006/relationships" xmlns:a="http://schemas.openxmlformats.org/drawingml/2006/main" r:embed="R02da6c568fa846c9"/>
           <a:stretch xmlns:a="http://schemas.openxmlformats.org/drawingml/2006/main">
             <a:fillRect l="0" t="0" r="0" b="0"/>
           </a:stretch>

</xml_diff>